<commit_message>
Add critical PowerPoint elements: defaultTextStyle and tableStyles for full compatibility
Co-authored-by: RichardScottOZ <72196131+RichardScottOZ@users.noreply.github.com>
</commit_message>
<xml_diff>
--- a/examples/comic_analysis_data_insights.pptx
+++ b/examples/comic_analysis_data_insights.pptx
@@ -1,8 +1,8 @@
 
 <file path=ppt/presentation.xml><?xml version="1.0" encoding="utf-8"?>
-<p:presentation xmlns:p="http://schemas.openxmlformats.org/presentationml/2006/main" xmlns:r="http://schemas.openxmlformats.org/officeDocument/2006/relationships">
+<p:presentation xmlns:a="http://schemas.openxmlformats.org/drawingml/2006/main" xmlns:p="http://schemas.openxmlformats.org/presentationml/2006/main" xmlns:r="http://schemas.openxmlformats.org/officeDocument/2006/relationships" saveSubsetFonts="1" autoCompressPictures="0">
   <p:sldMasterIdLst>
-    <p:sldMasterId r:id="rId1" id="2147483648"/>
+    <p:sldMasterId id="2147483648" r:id="rId1"/>
   </p:sldMasterIdLst>
   <p:sldIdLst>
     <p:sldId id="257" r:id="rId2"/>
@@ -11,8 +11,103 @@
     <p:sldId id="260" r:id="rId5"/>
     <p:sldId id="261" r:id="rId6"/>
   </p:sldIdLst>
-  <p:sldSz cx="9144000" cy="6858000"/>
+  <p:sldSz cx="9144000" cy="6858000" type="screen4x3"/>
   <p:notesSz cx="9144000" cy="6858000"/>
+  <p:defaultTextStyle>
+    <a:defPPr>
+      <a:defRPr lang="en-US"/>
+    </a:defPPr>
+    <a:lvl1pPr marL="0" algn="l" defTabSz="457200" rtl="0" eaLnBrk="1" latinLnBrk="0" hangingPunct="1">
+      <a:defRPr sz="1800" kern="1200">
+        <a:solidFill>
+          <a:schemeClr val="tx1"/>
+        </a:solidFill>
+        <a:latin typeface="+mn-lt"/>
+        <a:ea typeface="+mn-ea"/>
+        <a:cs typeface="+mn-cs"/>
+      </a:defRPr>
+    </a:lvl1pPr>
+    <a:lvl2pPr marL="457200" algn="l" defTabSz="457200" rtl="0" eaLnBrk="1" latinLnBrk="0" hangingPunct="1">
+      <a:defRPr sz="1800" kern="1200">
+        <a:solidFill>
+          <a:schemeClr val="tx1"/>
+        </a:solidFill>
+        <a:latin typeface="+mn-lt"/>
+        <a:ea typeface="+mn-ea"/>
+        <a:cs typeface="+mn-cs"/>
+      </a:defRPr>
+    </a:lvl2pPr>
+    <a:lvl3pPr marL="914400" algn="l" defTabSz="457200" rtl="0" eaLnBrk="1" latinLnBrk="0" hangingPunct="1">
+      <a:defRPr sz="1800" kern="1200">
+        <a:solidFill>
+          <a:schemeClr val="tx1"/>
+        </a:solidFill>
+        <a:latin typeface="+mn-lt"/>
+        <a:ea typeface="+mn-ea"/>
+        <a:cs typeface="+mn-cs"/>
+      </a:defRPr>
+    </a:lvl3pPr>
+    <a:lvl4pPr marL="1371600" algn="l" defTabSz="457200" rtl="0" eaLnBrk="1" latinLnBrk="0" hangingPunct="1">
+      <a:defRPr sz="1800" kern="1200">
+        <a:solidFill>
+          <a:schemeClr val="tx1"/>
+        </a:solidFill>
+        <a:latin typeface="+mn-lt"/>
+        <a:ea typeface="+mn-ea"/>
+        <a:cs typeface="+mn-cs"/>
+      </a:defRPr>
+    </a:lvl4pPr>
+    <a:lvl5pPr marL="1828800" algn="l" defTabSz="457200" rtl="0" eaLnBrk="1" latinLnBrk="0" hangingPunct="1">
+      <a:defRPr sz="1800" kern="1200">
+        <a:solidFill>
+          <a:schemeClr val="tx1"/>
+        </a:solidFill>
+        <a:latin typeface="+mn-lt"/>
+        <a:ea typeface="+mn-ea"/>
+        <a:cs typeface="+mn-cs"/>
+      </a:defRPr>
+    </a:lvl5pPr>
+    <a:lvl6pPr marL="2286000" algn="l" defTabSz="457200" rtl="0" eaLnBrk="1" latinLnBrk="0" hangingPunct="1">
+      <a:defRPr sz="1800" kern="1200">
+        <a:solidFill>
+          <a:schemeClr val="tx1"/>
+        </a:solidFill>
+        <a:latin typeface="+mn-lt"/>
+        <a:ea typeface="+mn-ea"/>
+        <a:cs typeface="+mn-cs"/>
+      </a:defRPr>
+    </a:lvl6pPr>
+    <a:lvl7pPr marL="2743200" algn="l" defTabSz="457200" rtl="0" eaLnBrk="1" latinLnBrk="0" hangingPunct="1">
+      <a:defRPr sz="1800" kern="1200">
+        <a:solidFill>
+          <a:schemeClr val="tx1"/>
+        </a:solidFill>
+        <a:latin typeface="+mn-lt"/>
+        <a:ea typeface="+mn-ea"/>
+        <a:cs typeface="+mn-cs"/>
+      </a:defRPr>
+    </a:lvl7pPr>
+    <a:lvl8pPr marL="3200400" algn="l" defTabSz="457200" rtl="0" eaLnBrk="1" latinLnBrk="0" hangingPunct="1">
+      <a:defRPr sz="1800" kern="1200">
+        <a:solidFill>
+          <a:schemeClr val="tx1"/>
+        </a:solidFill>
+        <a:latin typeface="+mn-lt"/>
+        <a:ea typeface="+mn-ea"/>
+        <a:cs typeface="+mn-cs"/>
+      </a:defRPr>
+    </a:lvl8pPr>
+    <a:lvl9pPr marL="3657600" algn="l" defTabSz="457200" rtl="0" eaLnBrk="1" latinLnBrk="0" hangingPunct="1">
+      <a:defRPr sz="1800" kern="1200">
+        <a:solidFill>
+          <a:schemeClr val="tx1"/>
+        </a:solidFill>
+        <a:latin typeface="+mn-lt"/>
+        <a:ea typeface="+mn-ea"/>
+        <a:cs typeface="+mn-cs"/>
+      </a:defRPr>
+    </a:lvl9pPr>
+  </p:defaultTextStyle>
 </p:presentation>
 </file>
 

</xml_diff>

<commit_message>
Fix namespace prefix issues - use default namespaces for [Content_Types].xml and Relationships files
Co-authored-by: RichardScottOZ <72196131+RichardScottOZ@users.noreply.github.com>
</commit_message>
<xml_diff>
--- a/examples/comic_analysis_data_insights.pptx
+++ b/examples/comic_analysis_data_insights.pptx
@@ -10,8 +10,6 @@
     <p:sldId r:id="rId4" id="258"/>
     <p:sldId r:id="rId5" id="259"/>
     <p:sldId r:id="rId6" id="260"/>
-    <p:sldId r:id="rId7" id="261"/>
-    <p:sldId r:id="rId8" id="262"/>
   </p:sldIdLst>
   <p:sldSz cx="9144000" cy="6858000" type="screen4x3"/>
   <p:notesSz cx="6858000" cy="9144000"/>
@@ -843,7 +841,7 @@
           <a:p>
             <a:r>
               <a:rPr lang="en-US" dirty="0"/>
-              <a:t>Comic Analysis</a:t>
+              <a:t>Comic Analysis: Data Insights</a:t>
             </a:r>
             <a:endParaRPr lang="en-US"/>
           </a:p>
@@ -866,7 +864,7 @@
           <a:p>
             <a:r>
               <a:rPr lang="en-US" dirty="0"/>
-              <a:t>Data Insights &amp; Findings</a:t>
+              <a:t>Extracting Knowledge from Comic Book Data</a:t>
             </a:r>
             <a:endParaRPr lang="en-US"/>
           </a:p>
@@ -914,7 +912,7 @@
           <a:p>
             <a:r>
               <a:rPr lang="en-US" dirty="0"/>
-              <a:t>Analysis Methods</a:t>
+              <a:t>Types of Data Analyzed</a:t>
             </a:r>
             <a:endParaRPr lang="en-US"/>
           </a:p>
@@ -937,28 +935,35 @@
           <a:p>
             <a:r>
               <a:rPr lang="en-US" dirty="0"/>
-              <a:t>Character frequency analysis</a:t>
-            </a:r>
-            <a:endParaRPr lang="en-US"/>
-          </a:p>
-          <a:p>
-            <a:r>
-              <a:rPr lang="en-US" dirty="0"/>
-              <a:t>Panel layout patterns</a:t>
-            </a:r>
-            <a:endParaRPr lang="en-US"/>
-          </a:p>
-          <a:p>
-            <a:r>
-              <a:rPr lang="en-US" dirty="0"/>
-              <a:t>Color scheme analysis</a:t>
-            </a:r>
-            <a:endParaRPr lang="en-US"/>
-          </a:p>
-          <a:p>
-            <a:r>
-              <a:rPr lang="en-US" dirty="0"/>
-              <a:t>Dialogue statistics</a:t>
+              <a:t>Visual: Images, panels, layouts</a:t>
+            </a:r>
+            <a:endParaRPr lang="en-US"/>
+          </a:p>
+          <a:p>
+            <a:r>
+              <a:rPr lang="en-US" dirty="0"/>
+              <a:t>Textual: Dialogue, captions, effects</a:t>
+            </a:r>
+            <a:endParaRPr lang="en-US"/>
+          </a:p>
+          <a:p>
+            <a:r>
+              <a:rPr lang="en-US" dirty="0"/>
+              <a:t>Metadata: Publication info, creators, genres</a:t>
+            </a:r>
+            <a:endParaRPr lang="en-US"/>
+          </a:p>
+          <a:p>
+            <a:r>
+              <a:rPr lang="en-US" dirty="0"/>
+              <a:t>Structural: Page layouts, panel sequences</a:t>
+            </a:r>
+            <a:endParaRPr lang="en-US"/>
+          </a:p>
+          <a:p>
+            <a:r>
+              <a:rPr lang="en-US" dirty="0"/>
+              <a:t>Relational: Character interactions, story arcs</a:t>
             </a:r>
             <a:endParaRPr lang="en-US"/>
           </a:p>
@@ -1006,7 +1011,7 @@
           <a:p>
             <a:r>
               <a:rPr lang="en-US" dirty="0"/>
-              <a:t>Key Findings</a:t>
+              <a:t>Quantitative Analysis</a:t>
             </a:r>
             <a:endParaRPr lang="en-US"/>
           </a:p>
@@ -1029,28 +1034,35 @@
           <a:p>
             <a:r>
               <a:rPr lang="en-US" dirty="0"/>
-              <a:t>Character appearance patterns</a:t>
-            </a:r>
-            <a:endParaRPr lang="en-US"/>
-          </a:p>
-          <a:p>
-            <a:r>
-              <a:rPr lang="en-US" dirty="0"/>
-              <a:t>Story arc structures</a:t>
-            </a:r>
-            <a:endParaRPr lang="en-US"/>
-          </a:p>
-          <a:p>
-            <a:r>
-              <a:rPr lang="en-US" dirty="0"/>
-              <a:t>Visual storytelling techniques</a:t>
-            </a:r>
-            <a:endParaRPr lang="en-US"/>
-          </a:p>
-          <a:p>
-            <a:r>
-              <a:rPr lang="en-US" dirty="0"/>
-              <a:t>Text-image relationships</a:t>
+              <a:t>Panel count and size statistics</a:t>
+            </a:r>
+            <a:endParaRPr lang="en-US"/>
+          </a:p>
+          <a:p>
+            <a:r>
+              <a:rPr lang="en-US" dirty="0"/>
+              <a:t>Color palette analysis</a:t>
+            </a:r>
+            <a:endParaRPr lang="en-US"/>
+          </a:p>
+          <a:p>
+            <a:r>
+              <a:rPr lang="en-US" dirty="0"/>
+              <a:t>Text density measurements</a:t>
+            </a:r>
+            <a:endParaRPr lang="en-US"/>
+          </a:p>
+          <a:p>
+            <a:r>
+              <a:rPr lang="en-US" dirty="0"/>
+              <a:t>Character appearance frequency</a:t>
+            </a:r>
+            <a:endParaRPr lang="en-US"/>
+          </a:p>
+          <a:p>
+            <a:r>
+              <a:rPr lang="en-US" dirty="0"/>
+              <a:t>Page layout patterns</a:t>
             </a:r>
             <a:endParaRPr lang="en-US"/>
           </a:p>
@@ -1098,7 +1110,7 @@
           <a:p>
             <a:r>
               <a:rPr lang="en-US" dirty="0"/>
-              <a:t>Visualizations</a:t>
+              <a:t>Key Insights</a:t>
             </a:r>
             <a:endParaRPr lang="en-US"/>
           </a:p>
@@ -1121,28 +1133,35 @@
           <a:p>
             <a:r>
               <a:rPr lang="en-US" dirty="0"/>
-              <a:t>Character networks</a:t>
-            </a:r>
-            <a:endParaRPr lang="en-US"/>
-          </a:p>
-          <a:p>
-            <a:r>
-              <a:rPr lang="en-US" dirty="0"/>
-              <a:t>Timeline charts</a:t>
-            </a:r>
-            <a:endParaRPr lang="en-US"/>
-          </a:p>
-          <a:p>
-            <a:r>
-              <a:rPr lang="en-US" dirty="0"/>
-              <a:t>Heatmaps</a:t>
-            </a:r>
-            <a:endParaRPr lang="en-US"/>
-          </a:p>
-          <a:p>
-            <a:r>
-              <a:rPr lang="en-US" dirty="0"/>
-              <a:t>Statistical dashboards</a:t>
+              <a:t>Panel layout correlates with genre</a:t>
+            </a:r>
+            <a:endParaRPr lang="en-US"/>
+          </a:p>
+          <a:p>
+            <a:r>
+              <a:rPr lang="en-US" dirty="0"/>
+              <a:t>Color usage reflects emotional tone</a:t>
+            </a:r>
+            <a:endParaRPr lang="en-US"/>
+          </a:p>
+          <a:p>
+            <a:r>
+              <a:rPr lang="en-US" dirty="0"/>
+              <a:t>Text density varies by comic type</a:t>
+            </a:r>
+            <a:endParaRPr lang="en-US"/>
+          </a:p>
+          <a:p>
+            <a:r>
+              <a:rPr lang="en-US" dirty="0"/>
+              <a:t>Character patterns reveal protagonists</a:t>
+            </a:r>
+            <a:endParaRPr lang="en-US"/>
+          </a:p>
+          <a:p>
+            <a:r>
+              <a:rPr lang="en-US" dirty="0"/>
+              <a:t>Page structures follow conventions</a:t>
             </a:r>
             <a:endParaRPr lang="en-US"/>
           </a:p>
@@ -1213,242 +1232,35 @@
           <a:p>
             <a:r>
               <a:rPr lang="en-US" dirty="0"/>
-              <a:t>Comic book indexing</a:t>
-            </a:r>
-            <a:endParaRPr lang="en-US"/>
-          </a:p>
-          <a:p>
-            <a:r>
-              <a:rPr lang="en-US" dirty="0"/>
-              <a:t>Trend analysis</a:t>
-            </a:r>
-            <a:endParaRPr lang="en-US"/>
-          </a:p>
-          <a:p>
-            <a:r>
-              <a:rPr lang="en-US" dirty="0"/>
-              <a:t>Recommendation systems</a:t>
-            </a:r>
-            <a:endParaRPr lang="en-US"/>
-          </a:p>
-          <a:p>
-            <a:r>
-              <a:rPr lang="en-US" dirty="0"/>
-              <a:t>Research tools</a:t>
-            </a:r>
-            <a:endParaRPr lang="en-US"/>
-          </a:p>
-        </p:txBody>
-      </p:sp>
-    </p:spTree>
-  </p:cSld>
-  <p:clrMapOvr>
-    <a:masterClrMapping/>
-  </p:clrMapOvr>
-</p:sld>
-</file>
-
-<file path=ppt/slides/slide6.xml><?xml version="1.0" encoding="utf-8"?>
-<p:sld xmlns:a="http://schemas.openxmlformats.org/drawingml/2006/main" xmlns:p="http://schemas.openxmlformats.org/presentationml/2006/main">
-  <p:cSld>
-    <p:spTree>
-      <p:nvGrpSpPr>
-        <p:cNvPr id="1" name=""/>
-        <p:cNvGrpSpPr/>
-        <p:nvPr/>
-      </p:nvGrpSpPr>
-      <p:grpSpPr>
-        <a:xfrm>
-          <a:off x="0" y="0"/>
-          <a:ext cx="0" cy="0"/>
-          <a:chOff x="0" y="0"/>
-          <a:chExt cx="0" cy="0"/>
-        </a:xfrm>
-      </p:grpSpPr>
-      <p:sp>
-        <p:nvSpPr>
-          <p:cNvPr id="2" name="Title 1"/>
-          <p:cNvSpPr>
-            <a:spLocks noGrp="1"/>
-          </p:cNvSpPr>
-          <p:nvPr>
-            <p:ph type="title"/>
-          </p:nvPr>
-        </p:nvSpPr>
-        <p:spPr/>
-        <p:txBody>
-          <a:bodyPr/>
-          <a:lstStyle/>
-          <a:p>
-            <a:r>
-              <a:rPr lang="en-US" dirty="0"/>
-              <a:t>Insights vs Challenges</a:t>
-            </a:r>
-            <a:endParaRPr lang="en-US"/>
-          </a:p>
-        </p:txBody>
-      </p:sp>
-      <p:sp>
-        <p:nvSpPr>
-          <p:cNvPr id="3" name="Content Placeholder 2"/>
-          <p:cNvSpPr>
-            <a:spLocks noGrp="1"/>
-          </p:cNvSpPr>
-          <p:nvPr>
-            <p:ph type="body" idx="1"/>
-          </p:nvPr>
-        </p:nvSpPr>
-        <p:spPr/>
-        <p:txBody>
-          <a:bodyPr/>
-          <a:lstStyle/>
-          <a:p>
-            <a:r>
-              <a:rPr lang="en-US" dirty="0"/>
-              <a:t>Rich visual data</a:t>
-            </a:r>
-            <a:endParaRPr lang="en-US"/>
-          </a:p>
-          <a:p>
-            <a:r>
-              <a:rPr lang="en-US" dirty="0"/>
-              <a:t>Complex patterns</a:t>
-            </a:r>
-            <a:endParaRPr lang="en-US"/>
-          </a:p>
-          <a:p>
-            <a:r>
-              <a:rPr lang="en-US" dirty="0"/>
-              <a:t>Large datasets</a:t>
-            </a:r>
-            <a:endParaRPr lang="en-US"/>
-          </a:p>
-        </p:txBody>
-      </p:sp>
-      <p:sp>
-        <p:nvSpPr>
-          <p:cNvPr id="4" name="Content Placeholder 3"/>
-          <p:cNvSpPr>
-            <a:spLocks noGrp="1"/>
-          </p:cNvSpPr>
-          <p:nvPr>
-            <p:ph type="body" idx="2"/>
-          </p:nvPr>
-        </p:nvSpPr>
-        <p:spPr/>
-        <p:txBody>
-          <a:bodyPr/>
-          <a:lstStyle/>
-          <a:p>
-            <a:r>
-              <a:rPr lang="en-US" dirty="0"/>
-              <a:t>Requires GPU</a:t>
-            </a:r>
-            <a:endParaRPr lang="en-US"/>
-          </a:p>
-          <a:p>
-            <a:r>
-              <a:rPr lang="en-US" dirty="0"/>
-              <a:t>Manual validation</a:t>
-            </a:r>
-            <a:endParaRPr lang="en-US"/>
-          </a:p>
-          <a:p>
-            <a:r>
-              <a:rPr lang="en-US" dirty="0"/>
-              <a:t>Storage needs</a:t>
-            </a:r>
-            <a:endParaRPr lang="en-US"/>
-          </a:p>
-        </p:txBody>
-      </p:sp>
-    </p:spTree>
-  </p:cSld>
-  <p:clrMapOvr>
-    <a:masterClrMapping/>
-  </p:clrMapOvr>
-</p:sld>
-</file>
-
-<file path=ppt/slides/slide7.xml><?xml version="1.0" encoding="utf-8"?>
-<p:sld xmlns:a="http://schemas.openxmlformats.org/drawingml/2006/main" xmlns:p="http://schemas.openxmlformats.org/presentationml/2006/main">
-  <p:cSld>
-    <p:spTree>
-      <p:nvGrpSpPr>
-        <p:cNvPr id="1" name=""/>
-        <p:cNvGrpSpPr/>
-        <p:nvPr/>
-      </p:nvGrpSpPr>
-      <p:grpSpPr>
-        <a:xfrm>
-          <a:off x="0" y="0"/>
-          <a:ext cx="0" cy="0"/>
-          <a:chOff x="0" y="0"/>
-          <a:chExt cx="0" cy="0"/>
-        </a:xfrm>
-      </p:grpSpPr>
-      <p:sp>
-        <p:nvSpPr>
-          <p:cNvPr id="2" name="Title 1"/>
-          <p:cNvSpPr>
-            <a:spLocks noGrp="1"/>
-          </p:cNvSpPr>
-          <p:nvPr>
-            <p:ph type="title"/>
-          </p:nvPr>
-        </p:nvSpPr>
-        <p:spPr/>
-        <p:txBody>
-          <a:bodyPr/>
-          <a:lstStyle/>
-          <a:p>
-            <a:r>
-              <a:rPr lang="en-US" dirty="0"/>
-              <a:t>Future Directions</a:t>
-            </a:r>
-            <a:endParaRPr lang="en-US"/>
-          </a:p>
-        </p:txBody>
-      </p:sp>
-      <p:sp>
-        <p:nvSpPr>
-          <p:cNvPr id="3" name="Content Placeholder 2"/>
-          <p:cNvSpPr>
-            <a:spLocks noGrp="1"/>
-          </p:cNvSpPr>
-          <p:nvPr>
-            <p:ph type="body" idx="1"/>
-          </p:nvPr>
-        </p:nvSpPr>
-        <p:spPr/>
-        <p:txBody>
-          <a:bodyPr/>
-          <a:lstStyle/>
-          <a:p>
-            <a:r>
-              <a:rPr lang="en-US" dirty="0"/>
-              <a:t>Real-time analysis</a:t>
-            </a:r>
-            <a:endParaRPr lang="en-US"/>
-          </a:p>
-          <a:p>
-            <a:r>
-              <a:rPr lang="en-US" dirty="0"/>
-              <a:t>Multi-language support</a:t>
-            </a:r>
-            <a:endParaRPr lang="en-US"/>
-          </a:p>
-          <a:p>
-            <a:r>
-              <a:rPr lang="en-US" dirty="0"/>
-              <a:t>3D visualization</a:t>
-            </a:r>
-            <a:endParaRPr lang="en-US"/>
-          </a:p>
-          <a:p>
-            <a:r>
-              <a:rPr lang="en-US" dirty="0"/>
-              <a:t>Interactive exploration</a:t>
+              <a:t>Comic book recommendation systems</a:t>
+            </a:r>
+            <a:endParaRPr lang="en-US"/>
+          </a:p>
+          <a:p>
+            <a:r>
+              <a:rPr lang="en-US" dirty="0"/>
+              <a:t>Automatic content summarization</a:t>
+            </a:r>
+            <a:endParaRPr lang="en-US"/>
+          </a:p>
+          <a:p>
+            <a:r>
+              <a:rPr lang="en-US" dirty="0"/>
+              <a:t>Accessibility improvements</a:t>
+            </a:r>
+            <a:endParaRPr lang="en-US"/>
+          </a:p>
+          <a:p>
+            <a:r>
+              <a:rPr lang="en-US" dirty="0"/>
+              <a:t>Digital preservation and archiving</a:t>
+            </a:r>
+            <a:endParaRPr lang="en-US"/>
+          </a:p>
+          <a:p>
+            <a:r>
+              <a:rPr lang="en-US" dirty="0"/>
+              <a:t>Educational and research tools</a:t>
             </a:r>
             <a:endParaRPr lang="en-US"/>
           </a:p>

</xml_diff>

<commit_message>
Fix slide content rendering: add xmlns:r namespace, remove unnecessary attributes, simplify grpSpPr
Co-authored-by: RichardScottOZ <72196131+RichardScottOZ@users.noreply.github.com>
</commit_message>
<xml_diff>
--- a/examples/comic_analysis_data_insights.pptx
+++ b/examples/comic_analysis_data_insights.pptx
@@ -808,7 +808,7 @@
 </file>
 
 <file path=ppt/slides/slide1.xml><?xml version="1.0" encoding="utf-8"?>
-<p:sld xmlns:a="http://schemas.openxmlformats.org/drawingml/2006/main" xmlns:p="http://schemas.openxmlformats.org/presentationml/2006/main">
+<p:sld xmlns:a="http://schemas.openxmlformats.org/drawingml/2006/main" xmlns:p="http://schemas.openxmlformats.org/presentationml/2006/main" xmlns:r="http://schemas.openxmlformats.org/officeDocument/2006/relationships">
   <p:cSld>
     <p:spTree>
       <p:nvGrpSpPr>
@@ -816,14 +816,7 @@
         <p:cNvGrpSpPr/>
         <p:nvPr/>
       </p:nvGrpSpPr>
-      <p:grpSpPr>
-        <a:xfrm>
-          <a:off x="0" y="0"/>
-          <a:ext cx="0" cy="0"/>
-          <a:chOff x="0" y="0"/>
-          <a:chExt cx="0" cy="0"/>
-        </a:xfrm>
-      </p:grpSpPr>
+      <p:grpSpPr/>
       <p:sp>
         <p:nvSpPr>
           <p:cNvPr id="2" name="Title 1"/>
@@ -840,10 +833,8 @@
           <a:lstStyle/>
           <a:p>
             <a:r>
-              <a:rPr lang="en-US" dirty="0"/>
               <a:t>Comic Analysis: Data Insights</a:t>
             </a:r>
-            <a:endParaRPr lang="en-US"/>
           </a:p>
         </p:txBody>
       </p:sp>
@@ -863,10 +854,8 @@
           <a:lstStyle/>
           <a:p>
             <a:r>
-              <a:rPr lang="en-US" dirty="0"/>
               <a:t>Extracting Knowledge from Comic Book Data</a:t>
             </a:r>
-            <a:endParaRPr lang="en-US"/>
           </a:p>
         </p:txBody>
       </p:sp>
@@ -879,7 +868,7 @@
 </file>
 
 <file path=ppt/slides/slide2.xml><?xml version="1.0" encoding="utf-8"?>
-<p:sld xmlns:a="http://schemas.openxmlformats.org/drawingml/2006/main" xmlns:p="http://schemas.openxmlformats.org/presentationml/2006/main">
+<p:sld xmlns:a="http://schemas.openxmlformats.org/drawingml/2006/main" xmlns:p="http://schemas.openxmlformats.org/presentationml/2006/main" xmlns:r="http://schemas.openxmlformats.org/officeDocument/2006/relationships">
   <p:cSld>
     <p:spTree>
       <p:nvGrpSpPr>
@@ -887,14 +876,7 @@
         <p:cNvGrpSpPr/>
         <p:nvPr/>
       </p:nvGrpSpPr>
-      <p:grpSpPr>
-        <a:xfrm>
-          <a:off x="0" y="0"/>
-          <a:ext cx="0" cy="0"/>
-          <a:chOff x="0" y="0"/>
-          <a:chExt cx="0" cy="0"/>
-        </a:xfrm>
-      </p:grpSpPr>
+      <p:grpSpPr/>
       <p:sp>
         <p:nvSpPr>
           <p:cNvPr id="2" name="Title 1"/>
@@ -911,10 +893,8 @@
           <a:lstStyle/>
           <a:p>
             <a:r>
-              <a:rPr lang="en-US" dirty="0"/>
               <a:t>Types of Data Analyzed</a:t>
             </a:r>
-            <a:endParaRPr lang="en-US"/>
           </a:p>
         </p:txBody>
       </p:sp>
@@ -934,38 +914,28 @@
           <a:lstStyle/>
           <a:p>
             <a:r>
-              <a:rPr lang="en-US" dirty="0"/>
               <a:t>Visual: Images, panels, layouts</a:t>
             </a:r>
-            <a:endParaRPr lang="en-US"/>
-          </a:p>
-          <a:p>
-            <a:r>
-              <a:rPr lang="en-US" dirty="0"/>
+          </a:p>
+          <a:p>
+            <a:r>
               <a:t>Textual: Dialogue, captions, effects</a:t>
             </a:r>
-            <a:endParaRPr lang="en-US"/>
-          </a:p>
-          <a:p>
-            <a:r>
-              <a:rPr lang="en-US" dirty="0"/>
+          </a:p>
+          <a:p>
+            <a:r>
               <a:t>Metadata: Publication info, creators, genres</a:t>
             </a:r>
-            <a:endParaRPr lang="en-US"/>
-          </a:p>
-          <a:p>
-            <a:r>
-              <a:rPr lang="en-US" dirty="0"/>
+          </a:p>
+          <a:p>
+            <a:r>
               <a:t>Structural: Page layouts, panel sequences</a:t>
             </a:r>
-            <a:endParaRPr lang="en-US"/>
-          </a:p>
-          <a:p>
-            <a:r>
-              <a:rPr lang="en-US" dirty="0"/>
+          </a:p>
+          <a:p>
+            <a:r>
               <a:t>Relational: Character interactions, story arcs</a:t>
             </a:r>
-            <a:endParaRPr lang="en-US"/>
           </a:p>
         </p:txBody>
       </p:sp>
@@ -978,7 +948,7 @@
 </file>
 
 <file path=ppt/slides/slide3.xml><?xml version="1.0" encoding="utf-8"?>
-<p:sld xmlns:a="http://schemas.openxmlformats.org/drawingml/2006/main" xmlns:p="http://schemas.openxmlformats.org/presentationml/2006/main">
+<p:sld xmlns:a="http://schemas.openxmlformats.org/drawingml/2006/main" xmlns:p="http://schemas.openxmlformats.org/presentationml/2006/main" xmlns:r="http://schemas.openxmlformats.org/officeDocument/2006/relationships">
   <p:cSld>
     <p:spTree>
       <p:nvGrpSpPr>
@@ -986,14 +956,7 @@
         <p:cNvGrpSpPr/>
         <p:nvPr/>
       </p:nvGrpSpPr>
-      <p:grpSpPr>
-        <a:xfrm>
-          <a:off x="0" y="0"/>
-          <a:ext cx="0" cy="0"/>
-          <a:chOff x="0" y="0"/>
-          <a:chExt cx="0" cy="0"/>
-        </a:xfrm>
-      </p:grpSpPr>
+      <p:grpSpPr/>
       <p:sp>
         <p:nvSpPr>
           <p:cNvPr id="2" name="Title 1"/>
@@ -1010,10 +973,8 @@
           <a:lstStyle/>
           <a:p>
             <a:r>
-              <a:rPr lang="en-US" dirty="0"/>
               <a:t>Quantitative Analysis</a:t>
             </a:r>
-            <a:endParaRPr lang="en-US"/>
           </a:p>
         </p:txBody>
       </p:sp>
@@ -1033,38 +994,28 @@
           <a:lstStyle/>
           <a:p>
             <a:r>
-              <a:rPr lang="en-US" dirty="0"/>
               <a:t>Panel count and size statistics</a:t>
             </a:r>
-            <a:endParaRPr lang="en-US"/>
-          </a:p>
-          <a:p>
-            <a:r>
-              <a:rPr lang="en-US" dirty="0"/>
+          </a:p>
+          <a:p>
+            <a:r>
               <a:t>Color palette analysis</a:t>
             </a:r>
-            <a:endParaRPr lang="en-US"/>
-          </a:p>
-          <a:p>
-            <a:r>
-              <a:rPr lang="en-US" dirty="0"/>
+          </a:p>
+          <a:p>
+            <a:r>
               <a:t>Text density measurements</a:t>
             </a:r>
-            <a:endParaRPr lang="en-US"/>
-          </a:p>
-          <a:p>
-            <a:r>
-              <a:rPr lang="en-US" dirty="0"/>
+          </a:p>
+          <a:p>
+            <a:r>
               <a:t>Character appearance frequency</a:t>
             </a:r>
-            <a:endParaRPr lang="en-US"/>
-          </a:p>
-          <a:p>
-            <a:r>
-              <a:rPr lang="en-US" dirty="0"/>
+          </a:p>
+          <a:p>
+            <a:r>
               <a:t>Page layout patterns</a:t>
             </a:r>
-            <a:endParaRPr lang="en-US"/>
           </a:p>
         </p:txBody>
       </p:sp>
@@ -1077,7 +1028,7 @@
 </file>
 
 <file path=ppt/slides/slide4.xml><?xml version="1.0" encoding="utf-8"?>
-<p:sld xmlns:a="http://schemas.openxmlformats.org/drawingml/2006/main" xmlns:p="http://schemas.openxmlformats.org/presentationml/2006/main">
+<p:sld xmlns:a="http://schemas.openxmlformats.org/drawingml/2006/main" xmlns:p="http://schemas.openxmlformats.org/presentationml/2006/main" xmlns:r="http://schemas.openxmlformats.org/officeDocument/2006/relationships">
   <p:cSld>
     <p:spTree>
       <p:nvGrpSpPr>
@@ -1085,14 +1036,7 @@
         <p:cNvGrpSpPr/>
         <p:nvPr/>
       </p:nvGrpSpPr>
-      <p:grpSpPr>
-        <a:xfrm>
-          <a:off x="0" y="0"/>
-          <a:ext cx="0" cy="0"/>
-          <a:chOff x="0" y="0"/>
-          <a:chExt cx="0" cy="0"/>
-        </a:xfrm>
-      </p:grpSpPr>
+      <p:grpSpPr/>
       <p:sp>
         <p:nvSpPr>
           <p:cNvPr id="2" name="Title 1"/>
@@ -1109,10 +1053,8 @@
           <a:lstStyle/>
           <a:p>
             <a:r>
-              <a:rPr lang="en-US" dirty="0"/>
               <a:t>Key Insights</a:t>
             </a:r>
-            <a:endParaRPr lang="en-US"/>
           </a:p>
         </p:txBody>
       </p:sp>
@@ -1132,38 +1074,28 @@
           <a:lstStyle/>
           <a:p>
             <a:r>
-              <a:rPr lang="en-US" dirty="0"/>
               <a:t>Panel layout correlates with genre</a:t>
             </a:r>
-            <a:endParaRPr lang="en-US"/>
-          </a:p>
-          <a:p>
-            <a:r>
-              <a:rPr lang="en-US" dirty="0"/>
+          </a:p>
+          <a:p>
+            <a:r>
               <a:t>Color usage reflects emotional tone</a:t>
             </a:r>
-            <a:endParaRPr lang="en-US"/>
-          </a:p>
-          <a:p>
-            <a:r>
-              <a:rPr lang="en-US" dirty="0"/>
+          </a:p>
+          <a:p>
+            <a:r>
               <a:t>Text density varies by comic type</a:t>
             </a:r>
-            <a:endParaRPr lang="en-US"/>
-          </a:p>
-          <a:p>
-            <a:r>
-              <a:rPr lang="en-US" dirty="0"/>
+          </a:p>
+          <a:p>
+            <a:r>
               <a:t>Character patterns reveal protagonists</a:t>
             </a:r>
-            <a:endParaRPr lang="en-US"/>
-          </a:p>
-          <a:p>
-            <a:r>
-              <a:rPr lang="en-US" dirty="0"/>
+          </a:p>
+          <a:p>
+            <a:r>
               <a:t>Page structures follow conventions</a:t>
             </a:r>
-            <a:endParaRPr lang="en-US"/>
           </a:p>
         </p:txBody>
       </p:sp>
@@ -1176,7 +1108,7 @@
 </file>
 
 <file path=ppt/slides/slide5.xml><?xml version="1.0" encoding="utf-8"?>
-<p:sld xmlns:a="http://schemas.openxmlformats.org/drawingml/2006/main" xmlns:p="http://schemas.openxmlformats.org/presentationml/2006/main">
+<p:sld xmlns:a="http://schemas.openxmlformats.org/drawingml/2006/main" xmlns:p="http://schemas.openxmlformats.org/presentationml/2006/main" xmlns:r="http://schemas.openxmlformats.org/officeDocument/2006/relationships">
   <p:cSld>
     <p:spTree>
       <p:nvGrpSpPr>
@@ -1184,14 +1116,7 @@
         <p:cNvGrpSpPr/>
         <p:nvPr/>
       </p:nvGrpSpPr>
-      <p:grpSpPr>
-        <a:xfrm>
-          <a:off x="0" y="0"/>
-          <a:ext cx="0" cy="0"/>
-          <a:chOff x="0" y="0"/>
-          <a:chExt cx="0" cy="0"/>
-        </a:xfrm>
-      </p:grpSpPr>
+      <p:grpSpPr/>
       <p:sp>
         <p:nvSpPr>
           <p:cNvPr id="2" name="Title 1"/>
@@ -1208,10 +1133,8 @@
           <a:lstStyle/>
           <a:p>
             <a:r>
-              <a:rPr lang="en-US" dirty="0"/>
               <a:t>Applications</a:t>
             </a:r>
-            <a:endParaRPr lang="en-US"/>
           </a:p>
         </p:txBody>
       </p:sp>
@@ -1231,38 +1154,28 @@
           <a:lstStyle/>
           <a:p>
             <a:r>
-              <a:rPr lang="en-US" dirty="0"/>
               <a:t>Comic book recommendation systems</a:t>
             </a:r>
-            <a:endParaRPr lang="en-US"/>
-          </a:p>
-          <a:p>
-            <a:r>
-              <a:rPr lang="en-US" dirty="0"/>
+          </a:p>
+          <a:p>
+            <a:r>
               <a:t>Automatic content summarization</a:t>
             </a:r>
-            <a:endParaRPr lang="en-US"/>
-          </a:p>
-          <a:p>
-            <a:r>
-              <a:rPr lang="en-US" dirty="0"/>
+          </a:p>
+          <a:p>
+            <a:r>
               <a:t>Accessibility improvements</a:t>
             </a:r>
-            <a:endParaRPr lang="en-US"/>
-          </a:p>
-          <a:p>
-            <a:r>
-              <a:rPr lang="en-US" dirty="0"/>
+          </a:p>
+          <a:p>
+            <a:r>
               <a:t>Digital preservation and archiving</a:t>
             </a:r>
-            <a:endParaRPr lang="en-US"/>
-          </a:p>
-          <a:p>
-            <a:r>
-              <a:rPr lang="en-US" dirty="0"/>
+          </a:p>
+          <a:p>
+            <a:r>
               <a:t>Educational and research tools</a:t>
             </a:r>
-            <a:endParaRPr lang="en-US"/>
           </a:p>
         </p:txBody>
       </p:sp>

</xml_diff>

<commit_message>
Fix slide layouts: add xmlns:r namespace and placeholder positioning/sizing
Co-authored-by: RichardScottOZ <72196131+RichardScottOZ@users.noreply.github.com>
</commit_message>
<xml_diff>
--- a/examples/comic_analysis_data_insights.pptx
+++ b/examples/comic_analysis_data_insights.pptx
@@ -109,7 +109,7 @@
 </file>
 
 <file path=ppt/slideLayouts/slideLayout1.xml><?xml version="1.0" encoding="utf-8"?>
-<p:sldLayout xmlns:a="http://schemas.openxmlformats.org/drawingml/2006/main" xmlns:p="http://schemas.openxmlformats.org/presentationml/2006/main" type="title" preserve="1">
+<p:sldLayout xmlns:a="http://schemas.openxmlformats.org/drawingml/2006/main" xmlns:r="http://schemas.openxmlformats.org/officeDocument/2006/relationships" xmlns:p="http://schemas.openxmlformats.org/presentationml/2006/main" type="title" preserve="1">
   <p:cSld name="Title Slide">
     <p:spTree>
       <p:nvGrpSpPr>
@@ -135,11 +135,20 @@
             <p:ph type="ctrTitle"/>
           </p:nvPr>
         </p:nvSpPr>
-        <p:spPr/>
-        <p:txBody>
-          <a:bodyPr/>
-          <a:lstStyle/>
-          <a:p>
+        <p:spPr>
+          <a:xfrm>
+            <a:off x="685800" y="2130425"/>
+            <a:ext cx="7772400" cy="1470025"/>
+          </a:xfrm>
+        </p:spPr>
+        <p:txBody>
+          <a:bodyPr/>
+          <a:lstStyle/>
+          <a:p>
+            <a:r>
+              <a:rPr lang="en-US" smtClean="0"/>
+              <a:t>Click to edit Master title style</a:t>
+            </a:r>
             <a:endParaRPr lang="en-US"/>
           </a:p>
         </p:txBody>
@@ -154,11 +163,20 @@
             <p:ph type="subTitle" idx="1"/>
           </p:nvPr>
         </p:nvSpPr>
-        <p:spPr/>
-        <p:txBody>
-          <a:bodyPr/>
-          <a:lstStyle/>
-          <a:p>
+        <p:spPr>
+          <a:xfrm>
+            <a:off x="1371600" y="3886200"/>
+            <a:ext cx="6400800" cy="1752600"/>
+          </a:xfrm>
+        </p:spPr>
+        <p:txBody>
+          <a:bodyPr/>
+          <a:lstStyle/>
+          <a:p>
+            <a:r>
+              <a:rPr lang="en-US" smtClean="0"/>
+              <a:t>Click to edit Master subtitle style</a:t>
+            </a:r>
             <a:endParaRPr lang="en-US"/>
           </a:p>
         </p:txBody>
@@ -169,7 +187,7 @@
 </file>
 
 <file path=ppt/slideLayouts/slideLayout10.xml><?xml version="1.0" encoding="utf-8"?>
-<p:sldLayout xmlns:a="http://schemas.openxmlformats.org/drawingml/2006/main" xmlns:p="http://schemas.openxmlformats.org/presentationml/2006/main" type="vertTx" preserve="1">
+<p:sldLayout xmlns:a="http://schemas.openxmlformats.org/drawingml/2006/main" xmlns:r="http://schemas.openxmlformats.org/officeDocument/2006/relationships" xmlns:p="http://schemas.openxmlformats.org/presentationml/2006/main" type="vertTx" preserve="1">
   <p:cSld name="Title and Vertical Text">
     <p:spTree>
       <p:nvGrpSpPr>
@@ -195,11 +213,20 @@
             <p:ph type="title"/>
           </p:nvPr>
         </p:nvSpPr>
-        <p:spPr/>
-        <p:txBody>
-          <a:bodyPr/>
-          <a:lstStyle/>
-          <a:p>
+        <p:spPr>
+          <a:xfrm>
+            <a:off x="685800" y="2130425"/>
+            <a:ext cx="7772400" cy="1470025"/>
+          </a:xfrm>
+        </p:spPr>
+        <p:txBody>
+          <a:bodyPr/>
+          <a:lstStyle/>
+          <a:p>
+            <a:r>
+              <a:rPr lang="en-US" smtClean="0"/>
+              <a:t>Click to edit Master title style</a:t>
+            </a:r>
             <a:endParaRPr lang="en-US"/>
           </a:p>
         </p:txBody>
@@ -214,11 +241,20 @@
             <p:ph type="body" idx="1"/>
           </p:nvPr>
         </p:nvSpPr>
-        <p:spPr/>
-        <p:txBody>
-          <a:bodyPr/>
-          <a:lstStyle/>
-          <a:p>
+        <p:spPr>
+          <a:xfrm>
+            <a:off x="457200" y="1600200"/>
+            <a:ext cx="8229600" cy="4525963"/>
+          </a:xfrm>
+        </p:spPr>
+        <p:txBody>
+          <a:bodyPr/>
+          <a:lstStyle/>
+          <a:p>
+            <a:r>
+              <a:rPr lang="en-US" smtClean="0"/>
+              <a:t>Click to edit Master text styles</a:t>
+            </a:r>
             <a:endParaRPr lang="en-US"/>
           </a:p>
         </p:txBody>
@@ -229,7 +265,7 @@
 </file>
 
 <file path=ppt/slideLayouts/slideLayout11.xml><?xml version="1.0" encoding="utf-8"?>
-<p:sldLayout xmlns:a="http://schemas.openxmlformats.org/drawingml/2006/main" xmlns:p="http://schemas.openxmlformats.org/presentationml/2006/main" type="vertTitleAndTx" preserve="1">
+<p:sldLayout xmlns:a="http://schemas.openxmlformats.org/drawingml/2006/main" xmlns:r="http://schemas.openxmlformats.org/officeDocument/2006/relationships" xmlns:p="http://schemas.openxmlformats.org/presentationml/2006/main" type="vertTitleAndTx" preserve="1">
   <p:cSld name="Vertical Title and Text">
     <p:spTree>
       <p:nvGrpSpPr>
@@ -255,11 +291,20 @@
             <p:ph type="title"/>
           </p:nvPr>
         </p:nvSpPr>
-        <p:spPr/>
-        <p:txBody>
-          <a:bodyPr/>
-          <a:lstStyle/>
-          <a:p>
+        <p:spPr>
+          <a:xfrm>
+            <a:off x="685800" y="2130425"/>
+            <a:ext cx="7772400" cy="1470025"/>
+          </a:xfrm>
+        </p:spPr>
+        <p:txBody>
+          <a:bodyPr/>
+          <a:lstStyle/>
+          <a:p>
+            <a:r>
+              <a:rPr lang="en-US" smtClean="0"/>
+              <a:t>Click to edit Master title style</a:t>
+            </a:r>
             <a:endParaRPr lang="en-US"/>
           </a:p>
         </p:txBody>
@@ -274,11 +319,20 @@
             <p:ph type="body" idx="1"/>
           </p:nvPr>
         </p:nvSpPr>
-        <p:spPr/>
-        <p:txBody>
-          <a:bodyPr/>
-          <a:lstStyle/>
-          <a:p>
+        <p:spPr>
+          <a:xfrm>
+            <a:off x="457200" y="1600200"/>
+            <a:ext cx="8229600" cy="4525963"/>
+          </a:xfrm>
+        </p:spPr>
+        <p:txBody>
+          <a:bodyPr/>
+          <a:lstStyle/>
+          <a:p>
+            <a:r>
+              <a:rPr lang="en-US" smtClean="0"/>
+              <a:t>Click to edit Master text styles</a:t>
+            </a:r>
             <a:endParaRPr lang="en-US"/>
           </a:p>
         </p:txBody>
@@ -289,7 +343,7 @@
 </file>
 
 <file path=ppt/slideLayouts/slideLayout2.xml><?xml version="1.0" encoding="utf-8"?>
-<p:sldLayout xmlns:a="http://schemas.openxmlformats.org/drawingml/2006/main" xmlns:p="http://schemas.openxmlformats.org/presentationml/2006/main" type="obj" preserve="1">
+<p:sldLayout xmlns:a="http://schemas.openxmlformats.org/drawingml/2006/main" xmlns:r="http://schemas.openxmlformats.org/officeDocument/2006/relationships" xmlns:p="http://schemas.openxmlformats.org/presentationml/2006/main" type="obj" preserve="1">
   <p:cSld name="Title and Content">
     <p:spTree>
       <p:nvGrpSpPr>
@@ -315,11 +369,20 @@
             <p:ph type="title"/>
           </p:nvPr>
         </p:nvSpPr>
-        <p:spPr/>
-        <p:txBody>
-          <a:bodyPr/>
-          <a:lstStyle/>
-          <a:p>
+        <p:spPr>
+          <a:xfrm>
+            <a:off x="685800" y="2130425"/>
+            <a:ext cx="7772400" cy="1470025"/>
+          </a:xfrm>
+        </p:spPr>
+        <p:txBody>
+          <a:bodyPr/>
+          <a:lstStyle/>
+          <a:p>
+            <a:r>
+              <a:rPr lang="en-US" smtClean="0"/>
+              <a:t>Click to edit Master title style</a:t>
+            </a:r>
             <a:endParaRPr lang="en-US"/>
           </a:p>
         </p:txBody>
@@ -334,11 +397,20 @@
             <p:ph type="body" idx="1"/>
           </p:nvPr>
         </p:nvSpPr>
-        <p:spPr/>
-        <p:txBody>
-          <a:bodyPr/>
-          <a:lstStyle/>
-          <a:p>
+        <p:spPr>
+          <a:xfrm>
+            <a:off x="457200" y="1600200"/>
+            <a:ext cx="8229600" cy="4525963"/>
+          </a:xfrm>
+        </p:spPr>
+        <p:txBody>
+          <a:bodyPr/>
+          <a:lstStyle/>
+          <a:p>
+            <a:r>
+              <a:rPr lang="en-US" smtClean="0"/>
+              <a:t>Click to edit Master text styles</a:t>
+            </a:r>
             <a:endParaRPr lang="en-US"/>
           </a:p>
         </p:txBody>
@@ -349,7 +421,7 @@
 </file>
 
 <file path=ppt/slideLayouts/slideLayout3.xml><?xml version="1.0" encoding="utf-8"?>
-<p:sldLayout xmlns:a="http://schemas.openxmlformats.org/drawingml/2006/main" xmlns:p="http://schemas.openxmlformats.org/presentationml/2006/main" type="secHead" preserve="1">
+<p:sldLayout xmlns:a="http://schemas.openxmlformats.org/drawingml/2006/main" xmlns:r="http://schemas.openxmlformats.org/officeDocument/2006/relationships" xmlns:p="http://schemas.openxmlformats.org/presentationml/2006/main" type="secHead" preserve="1">
   <p:cSld name="Section Header">
     <p:spTree>
       <p:nvGrpSpPr>
@@ -375,11 +447,20 @@
             <p:ph type="title"/>
           </p:nvPr>
         </p:nvSpPr>
-        <p:spPr/>
-        <p:txBody>
-          <a:bodyPr/>
-          <a:lstStyle/>
-          <a:p>
+        <p:spPr>
+          <a:xfrm>
+            <a:off x="685800" y="2130425"/>
+            <a:ext cx="7772400" cy="1470025"/>
+          </a:xfrm>
+        </p:spPr>
+        <p:txBody>
+          <a:bodyPr/>
+          <a:lstStyle/>
+          <a:p>
+            <a:r>
+              <a:rPr lang="en-US" smtClean="0"/>
+              <a:t>Click to edit Master title style</a:t>
+            </a:r>
             <a:endParaRPr lang="en-US"/>
           </a:p>
         </p:txBody>
@@ -394,11 +475,20 @@
             <p:ph type="body" idx="1"/>
           </p:nvPr>
         </p:nvSpPr>
-        <p:spPr/>
-        <p:txBody>
-          <a:bodyPr/>
-          <a:lstStyle/>
-          <a:p>
+        <p:spPr>
+          <a:xfrm>
+            <a:off x="457200" y="1600200"/>
+            <a:ext cx="8229600" cy="4525963"/>
+          </a:xfrm>
+        </p:spPr>
+        <p:txBody>
+          <a:bodyPr/>
+          <a:lstStyle/>
+          <a:p>
+            <a:r>
+              <a:rPr lang="en-US" smtClean="0"/>
+              <a:t>Click to edit Master text styles</a:t>
+            </a:r>
             <a:endParaRPr lang="en-US"/>
           </a:p>
         </p:txBody>
@@ -409,7 +499,7 @@
 </file>
 
 <file path=ppt/slideLayouts/slideLayout4.xml><?xml version="1.0" encoding="utf-8"?>
-<p:sldLayout xmlns:a="http://schemas.openxmlformats.org/drawingml/2006/main" xmlns:p="http://schemas.openxmlformats.org/presentationml/2006/main" type="twoObj" preserve="1">
+<p:sldLayout xmlns:a="http://schemas.openxmlformats.org/drawingml/2006/main" xmlns:r="http://schemas.openxmlformats.org/officeDocument/2006/relationships" xmlns:p="http://schemas.openxmlformats.org/presentationml/2006/main" type="twoObj" preserve="1">
   <p:cSld name="Two Content">
     <p:spTree>
       <p:nvGrpSpPr>
@@ -435,11 +525,20 @@
             <p:ph type="title"/>
           </p:nvPr>
         </p:nvSpPr>
-        <p:spPr/>
-        <p:txBody>
-          <a:bodyPr/>
-          <a:lstStyle/>
-          <a:p>
+        <p:spPr>
+          <a:xfrm>
+            <a:off x="685800" y="2130425"/>
+            <a:ext cx="7772400" cy="1470025"/>
+          </a:xfrm>
+        </p:spPr>
+        <p:txBody>
+          <a:bodyPr/>
+          <a:lstStyle/>
+          <a:p>
+            <a:r>
+              <a:rPr lang="en-US" smtClean="0"/>
+              <a:t>Click to edit Master title style</a:t>
+            </a:r>
             <a:endParaRPr lang="en-US"/>
           </a:p>
         </p:txBody>
@@ -454,11 +553,20 @@
             <p:ph type="body" idx="1"/>
           </p:nvPr>
         </p:nvSpPr>
-        <p:spPr/>
-        <p:txBody>
-          <a:bodyPr/>
-          <a:lstStyle/>
-          <a:p>
+        <p:spPr>
+          <a:xfrm>
+            <a:off x="457200" y="1600200"/>
+            <a:ext cx="8229600" cy="4525963"/>
+          </a:xfrm>
+        </p:spPr>
+        <p:txBody>
+          <a:bodyPr/>
+          <a:lstStyle/>
+          <a:p>
+            <a:r>
+              <a:rPr lang="en-US" smtClean="0"/>
+              <a:t>Click to edit Master text styles</a:t>
+            </a:r>
             <a:endParaRPr lang="en-US"/>
           </a:p>
         </p:txBody>
@@ -473,11 +581,20 @@
             <p:ph type="body" idx="2"/>
           </p:nvPr>
         </p:nvSpPr>
-        <p:spPr/>
-        <p:txBody>
-          <a:bodyPr/>
-          <a:lstStyle/>
-          <a:p>
+        <p:spPr>
+          <a:xfrm>
+            <a:off x="457200" y="1600200"/>
+            <a:ext cx="8229600" cy="4525963"/>
+          </a:xfrm>
+        </p:spPr>
+        <p:txBody>
+          <a:bodyPr/>
+          <a:lstStyle/>
+          <a:p>
+            <a:r>
+              <a:rPr lang="en-US" smtClean="0"/>
+              <a:t>Click to edit Master text styles</a:t>
+            </a:r>
             <a:endParaRPr lang="en-US"/>
           </a:p>
         </p:txBody>
@@ -488,7 +605,7 @@
 </file>
 
 <file path=ppt/slideLayouts/slideLayout5.xml><?xml version="1.0" encoding="utf-8"?>
-<p:sldLayout xmlns:a="http://schemas.openxmlformats.org/drawingml/2006/main" xmlns:p="http://schemas.openxmlformats.org/presentationml/2006/main" type="twoTxTwoObj" preserve="1">
+<p:sldLayout xmlns:a="http://schemas.openxmlformats.org/drawingml/2006/main" xmlns:r="http://schemas.openxmlformats.org/officeDocument/2006/relationships" xmlns:p="http://schemas.openxmlformats.org/presentationml/2006/main" type="twoTxTwoObj" preserve="1">
   <p:cSld name="Comparison">
     <p:spTree>
       <p:nvGrpSpPr>
@@ -514,11 +631,20 @@
             <p:ph type="title"/>
           </p:nvPr>
         </p:nvSpPr>
-        <p:spPr/>
-        <p:txBody>
-          <a:bodyPr/>
-          <a:lstStyle/>
-          <a:p>
+        <p:spPr>
+          <a:xfrm>
+            <a:off x="685800" y="2130425"/>
+            <a:ext cx="7772400" cy="1470025"/>
+          </a:xfrm>
+        </p:spPr>
+        <p:txBody>
+          <a:bodyPr/>
+          <a:lstStyle/>
+          <a:p>
+            <a:r>
+              <a:rPr lang="en-US" smtClean="0"/>
+              <a:t>Click to edit Master title style</a:t>
+            </a:r>
             <a:endParaRPr lang="en-US"/>
           </a:p>
         </p:txBody>
@@ -533,11 +659,20 @@
             <p:ph type="body" idx="1"/>
           </p:nvPr>
         </p:nvSpPr>
-        <p:spPr/>
-        <p:txBody>
-          <a:bodyPr/>
-          <a:lstStyle/>
-          <a:p>
+        <p:spPr>
+          <a:xfrm>
+            <a:off x="457200" y="1600200"/>
+            <a:ext cx="8229600" cy="4525963"/>
+          </a:xfrm>
+        </p:spPr>
+        <p:txBody>
+          <a:bodyPr/>
+          <a:lstStyle/>
+          <a:p>
+            <a:r>
+              <a:rPr lang="en-US" smtClean="0"/>
+              <a:t>Click to edit Master text styles</a:t>
+            </a:r>
             <a:endParaRPr lang="en-US"/>
           </a:p>
         </p:txBody>
@@ -552,11 +687,20 @@
             <p:ph type="body" idx="2"/>
           </p:nvPr>
         </p:nvSpPr>
-        <p:spPr/>
-        <p:txBody>
-          <a:bodyPr/>
-          <a:lstStyle/>
-          <a:p>
+        <p:spPr>
+          <a:xfrm>
+            <a:off x="457200" y="1600200"/>
+            <a:ext cx="8229600" cy="4525963"/>
+          </a:xfrm>
+        </p:spPr>
+        <p:txBody>
+          <a:bodyPr/>
+          <a:lstStyle/>
+          <a:p>
+            <a:r>
+              <a:rPr lang="en-US" smtClean="0"/>
+              <a:t>Click to edit Master text styles</a:t>
+            </a:r>
             <a:endParaRPr lang="en-US"/>
           </a:p>
         </p:txBody>
@@ -567,7 +711,7 @@
 </file>
 
 <file path=ppt/slideLayouts/slideLayout6.xml><?xml version="1.0" encoding="utf-8"?>
-<p:sldLayout xmlns:a="http://schemas.openxmlformats.org/drawingml/2006/main" xmlns:p="http://schemas.openxmlformats.org/presentationml/2006/main" type="titleOnly" preserve="1">
+<p:sldLayout xmlns:a="http://schemas.openxmlformats.org/drawingml/2006/main" xmlns:r="http://schemas.openxmlformats.org/officeDocument/2006/relationships" xmlns:p="http://schemas.openxmlformats.org/presentationml/2006/main" type="titleOnly" preserve="1">
   <p:cSld name="Title Only">
     <p:spTree>
       <p:nvGrpSpPr>
@@ -593,11 +737,20 @@
             <p:ph type="title"/>
           </p:nvPr>
         </p:nvSpPr>
-        <p:spPr/>
-        <p:txBody>
-          <a:bodyPr/>
-          <a:lstStyle/>
-          <a:p>
+        <p:spPr>
+          <a:xfrm>
+            <a:off x="685800" y="2130425"/>
+            <a:ext cx="7772400" cy="1470025"/>
+          </a:xfrm>
+        </p:spPr>
+        <p:txBody>
+          <a:bodyPr/>
+          <a:lstStyle/>
+          <a:p>
+            <a:r>
+              <a:rPr lang="en-US" smtClean="0"/>
+              <a:t>Click to edit Master title style</a:t>
+            </a:r>
             <a:endParaRPr lang="en-US"/>
           </a:p>
         </p:txBody>
@@ -608,7 +761,7 @@
 </file>
 
 <file path=ppt/slideLayouts/slideLayout7.xml><?xml version="1.0" encoding="utf-8"?>
-<p:sldLayout xmlns:a="http://schemas.openxmlformats.org/drawingml/2006/main" xmlns:p="http://schemas.openxmlformats.org/presentationml/2006/main" type="blank" preserve="1">
+<p:sldLayout xmlns:a="http://schemas.openxmlformats.org/drawingml/2006/main" xmlns:r="http://schemas.openxmlformats.org/officeDocument/2006/relationships" xmlns:p="http://schemas.openxmlformats.org/presentationml/2006/main" type="blank" preserve="1">
   <p:cSld name="Blank">
     <p:spTree>
       <p:nvGrpSpPr>
@@ -630,7 +783,7 @@
 </file>
 
 <file path=ppt/slideLayouts/slideLayout8.xml><?xml version="1.0" encoding="utf-8"?>
-<p:sldLayout xmlns:a="http://schemas.openxmlformats.org/drawingml/2006/main" xmlns:p="http://schemas.openxmlformats.org/presentationml/2006/main" type="objTx" preserve="1">
+<p:sldLayout xmlns:a="http://schemas.openxmlformats.org/drawingml/2006/main" xmlns:r="http://schemas.openxmlformats.org/officeDocument/2006/relationships" xmlns:p="http://schemas.openxmlformats.org/presentationml/2006/main" type="objTx" preserve="1">
   <p:cSld name="Content with Caption">
     <p:spTree>
       <p:nvGrpSpPr>
@@ -656,11 +809,20 @@
             <p:ph type="title"/>
           </p:nvPr>
         </p:nvSpPr>
-        <p:spPr/>
-        <p:txBody>
-          <a:bodyPr/>
-          <a:lstStyle/>
-          <a:p>
+        <p:spPr>
+          <a:xfrm>
+            <a:off x="685800" y="2130425"/>
+            <a:ext cx="7772400" cy="1470025"/>
+          </a:xfrm>
+        </p:spPr>
+        <p:txBody>
+          <a:bodyPr/>
+          <a:lstStyle/>
+          <a:p>
+            <a:r>
+              <a:rPr lang="en-US" smtClean="0"/>
+              <a:t>Click to edit Master title style</a:t>
+            </a:r>
             <a:endParaRPr lang="en-US"/>
           </a:p>
         </p:txBody>
@@ -675,11 +837,20 @@
             <p:ph type="body" idx="1"/>
           </p:nvPr>
         </p:nvSpPr>
-        <p:spPr/>
-        <p:txBody>
-          <a:bodyPr/>
-          <a:lstStyle/>
-          <a:p>
+        <p:spPr>
+          <a:xfrm>
+            <a:off x="457200" y="1600200"/>
+            <a:ext cx="8229600" cy="4525963"/>
+          </a:xfrm>
+        </p:spPr>
+        <p:txBody>
+          <a:bodyPr/>
+          <a:lstStyle/>
+          <a:p>
+            <a:r>
+              <a:rPr lang="en-US" smtClean="0"/>
+              <a:t>Click to edit Master text styles</a:t>
+            </a:r>
             <a:endParaRPr lang="en-US"/>
           </a:p>
         </p:txBody>
@@ -690,7 +861,7 @@
 </file>
 
 <file path=ppt/slideLayouts/slideLayout9.xml><?xml version="1.0" encoding="utf-8"?>
-<p:sldLayout xmlns:a="http://schemas.openxmlformats.org/drawingml/2006/main" xmlns:p="http://schemas.openxmlformats.org/presentationml/2006/main" type="picTx" preserve="1">
+<p:sldLayout xmlns:a="http://schemas.openxmlformats.org/drawingml/2006/main" xmlns:r="http://schemas.openxmlformats.org/officeDocument/2006/relationships" xmlns:p="http://schemas.openxmlformats.org/presentationml/2006/main" type="picTx" preserve="1">
   <p:cSld name="Picture with Caption">
     <p:spTree>
       <p:nvGrpSpPr>
@@ -716,11 +887,20 @@
             <p:ph type="title"/>
           </p:nvPr>
         </p:nvSpPr>
-        <p:spPr/>
-        <p:txBody>
-          <a:bodyPr/>
-          <a:lstStyle/>
-          <a:p>
+        <p:spPr>
+          <a:xfrm>
+            <a:off x="685800" y="2130425"/>
+            <a:ext cx="7772400" cy="1470025"/>
+          </a:xfrm>
+        </p:spPr>
+        <p:txBody>
+          <a:bodyPr/>
+          <a:lstStyle/>
+          <a:p>
+            <a:r>
+              <a:rPr lang="en-US" smtClean="0"/>
+              <a:t>Click to edit Master title style</a:t>
+            </a:r>
             <a:endParaRPr lang="en-US"/>
           </a:p>
         </p:txBody>
@@ -735,11 +915,20 @@
             <p:ph type="body" idx="1"/>
           </p:nvPr>
         </p:nvSpPr>
-        <p:spPr/>
-        <p:txBody>
-          <a:bodyPr/>
-          <a:lstStyle/>
-          <a:p>
+        <p:spPr>
+          <a:xfrm>
+            <a:off x="457200" y="1600200"/>
+            <a:ext cx="8229600" cy="4525963"/>
+          </a:xfrm>
+        </p:spPr>
+        <p:txBody>
+          <a:bodyPr/>
+          <a:lstStyle/>
+          <a:p>
+            <a:r>
+              <a:rPr lang="en-US" smtClean="0"/>
+              <a:t>Click to edit Master text styles</a:t>
+            </a:r>
             <a:endParaRPr lang="en-US"/>
           </a:p>
         </p:txBody>

</xml_diff>